<commit_message>
Lead the demo deck's Hangul payload lines with English labels
</commit_message>
<xml_diff>
--- a/examples/broken_en.pptx
+++ b/examples/broken_en.pptx
@@ -3152,7 +3152,7 @@
                 </a:solidFill>
                 <a:latin typeface="Arial"/>
               </a:rPr>
-              <a:t>한국어 요약: 구독 매출이 성장을 견인</a:t>
+              <a:t>Korean summary: 구독 매출이 성장을 견인했습니다</a:t>
             </a:r>
           </a:p>
         </p:txBody>
@@ -3220,7 +3220,7 @@
                 </a:solidFill>
                 <a:ea typeface="맑은 고딕"/>
               </a:rPr>
-              <a:t>자간이 벌어진 한글 라벨</a:t>
+              <a:t>Hangul label with tracking: 자간 데모</a:t>
             </a:r>
           </a:p>
         </p:txBody>

</xml_diff>